<commit_message>
feat: minpack request, batch FIFO, i18n full coverage, urgent flag, AD auth, docker
</commit_message>
<xml_diff>
--- a/物料领取看板系统培训.pptx
+++ b/物料领取看板系统培训.pptx
@@ -3502,7 +3502,7 @@
                 <a:latin typeface="Arial" panose="020B0604020202020204" pitchFamily="34" charset="0"/>
                 <a:cs typeface="Arial" panose="020B0604020202020204" pitchFamily="34" charset="0"/>
               </a:rPr>
-              <a:t>文档需要打印，无法实时查询物料库存量</a:t>
+              <a:t>文档，无法实时查询物料库存量</a:t>
             </a:r>
             <a:endParaRPr lang="en-US" sz="1100" dirty="0">
               <a:solidFill>
@@ -3830,7 +3830,7 @@
                 <a:latin typeface="Arial" panose="020B0604020202020204" pitchFamily="34" charset="0"/>
                 <a:cs typeface="Arial" panose="020B0604020202020204" pitchFamily="34" charset="0"/>
               </a:rPr>
-              <a:t>纸本记录不便于查询申请状况，数据追溯查找</a:t>
+              <a:t>纸本记录不便于查询申请状况，很难数据追溯</a:t>
             </a:r>
             <a:endParaRPr lang="en-US" sz="1100" dirty="0">
               <a:latin typeface="Arial" panose="020B0604020202020204" pitchFamily="34" charset="0"/>

</xml_diff>